<commit_message>
搬入 WSL恢復.md 並把 W2 的 WSL／python_basic 連結改指 tw-selfselect
- 新增 WSL恢復.md（自母專案改寫：路徑/remote 改 tw-selfselect、備份夾名 tw_selfselect_backup、
  移除加密主程式還原步驟〔本專案為公開源碼〕、.env 範本指向 .env.example.txt）
- W2 s2：WSL恢復.md 連結（3 段）改指 tw-selfselect repo（URL-encoded）；
  python_basic（預先準備.MD／1-wsl-guide.md）連結移除（本專案未收錄該教材）
- 保留「申請 git 帳戶」等 github.com 通用連結
</commit_message>
<xml_diff>
--- a/plans/ppt/TW-SELFSELECT台股買賣自動化系統-W2-講稿版.pptx
+++ b/plans/ppt/TW-SELFSELECT台股買賣自動化系統-W2-講稿版.pptx
@@ -20485,7 +20485,7 @@
                 <a:uFillTx/>
                 <a:latin typeface="Century Gothic"/>
                 <a:ea typeface="Century Gothic"/>
-                <a:hlinkClick r:id="rId2"/>
+                <a:hlinkClick r:id="rId9"/>
               </a:rPr>
               <a:t>WSL</a:t>
             </a:r>
@@ -20501,7 +20501,7 @@
                 <a:uFillTx/>
                 <a:latin typeface="Century Gothic"/>
                 <a:ea typeface="Century Gothic"/>
-                <a:hlinkClick r:id="rId2"/>
+                <a:hlinkClick r:id="rId9"/>
               </a:rPr>
               <a:t>恢復</a:t>
             </a:r>
@@ -20517,7 +20517,7 @@
                 <a:uFillTx/>
                 <a:latin typeface="Century Gothic"/>
                 <a:ea typeface="Century Gothic"/>
-                <a:hlinkClick r:id="rId2"/>
+                <a:hlinkClick r:id="rId9"/>
               </a:rPr>
               <a:t>.md</a:t>
             </a:r>
@@ -20608,7 +20608,6 @@
                 <a:uFillTx/>
                 <a:latin typeface="Century Gothic"/>
                 <a:ea typeface="Century Gothic"/>
-                <a:hlinkClick r:id="rId3"/>
               </a:rPr>
               <a:t>安裝程式</a:t>
             </a:r>
@@ -20962,7 +20961,6 @@
                 <a:uFillTx/>
                 <a:latin typeface="Century Gothic"/>
                 <a:ea typeface="Century Gothic"/>
-                <a:hlinkClick r:id="rId5"/>
               </a:rPr>
               <a:t>wsl</a:t>
             </a:r>
@@ -20978,7 +20976,6 @@
                 <a:uFillTx/>
                 <a:latin typeface="Century Gothic"/>
                 <a:ea typeface="Century Gothic"/>
-                <a:hlinkClick r:id="rId5"/>
               </a:rPr>
               <a:t>簡易說明</a:t>
             </a:r>

</xml_diff>

<commit_message>
搬入 python_basic 教材（改名/品牌改 tw-selfselect＋DSH）
- 新增 python_basic/（23 個檔案，約 108KB）：WSL/GCP/PyCharm 準備、W1–W8 範例與教材、data/
- 內容全數由 tw-autotrader→tw-selfselect、opencode→DSH 改寫；
  week-07-opencode_practice.py → week-07-dsh_practice.py（README/教材引用同步）
- W2 s2：python_basic 的「安裝程式（預先準備.MD）」「wsl／簡易說明（1-wsl-guide.md）」連結接回
  tw-selfselect repo（URL-encoded）
</commit_message>
<xml_diff>
--- a/plans/ppt/TW-SELFSELECT台股買賣自動化系統-W2-講稿版.pptx
+++ b/plans/ppt/TW-SELFSELECT台股買賣自動化系統-W2-講稿版.pptx
@@ -20448,6 +20448,9 @@
               <a:lnSpc>
                 <a:spcPts val="2160"/>
               </a:lnSpc>
+              <a:spcAft>
+                <a:spcPts val="300"/>
+              </a:spcAft>
               <a:buClr>
                 <a:srgbClr val="595959"/>
               </a:buClr>
@@ -20459,7 +20462,7 @@
               </a:tabLst>
             </a:pPr>
             <a:r>
-              <a:rPr lang="zh-TW" sz="1800" b="0" u="none" strike="noStrike">
+              <a:rPr lang="zh-TW" sz="1400" b="0" u="none" strike="noStrike">
                 <a:solidFill>
                   <a:schemeClr val="dk1">
                     <a:lumMod val="85000"/>
@@ -20474,7 +20477,7 @@
               <a:t>依照</a:t>
             </a:r>
             <a:r>
-              <a:rPr lang="en-US" sz="1800" b="0" u="sng" strike="noStrike">
+              <a:rPr lang="en-US" sz="1400" b="0" u="sng" strike="noStrike">
                 <a:solidFill>
                   <a:schemeClr val="dk1">
                     <a:lumMod val="85000"/>
@@ -20490,7 +20493,7 @@
               <a:t>WSL</a:t>
             </a:r>
             <a:r>
-              <a:rPr lang="zh-TW" sz="1800" b="0" u="sng" strike="noStrike">
+              <a:rPr lang="zh-TW" sz="1400" b="0" u="sng" strike="noStrike">
                 <a:solidFill>
                   <a:schemeClr val="dk1">
                     <a:lumMod val="85000"/>
@@ -20506,7 +20509,7 @@
               <a:t>恢復</a:t>
             </a:r>
             <a:r>
-              <a:rPr lang="en-US" sz="1800" b="0" u="sng" strike="noStrike">
+              <a:rPr lang="en-US" sz="1400" b="0" u="sng" strike="noStrike">
                 <a:solidFill>
                   <a:schemeClr val="dk1">
                     <a:lumMod val="85000"/>
@@ -20522,7 +20525,7 @@
               <a:t>.md</a:t>
             </a:r>
             <a:r>
-              <a:rPr lang="zh-TW" sz="1800" b="0" u="none" strike="noStrike">
+              <a:rPr lang="zh-TW" sz="1400" b="0" u="none" strike="noStrike">
                 <a:solidFill>
                   <a:schemeClr val="dk1">
                     <a:lumMod val="85000"/>
@@ -20537,7 +20540,7 @@
               <a:t>中的恢復步驟把</a:t>
             </a:r>
             <a:r>
-              <a:rPr lang="en-US" sz="1800" b="0" u="none" strike="noStrike">
+              <a:rPr lang="en-US" sz="1400" b="0" u="none" strike="noStrike">
                 <a:solidFill>
                   <a:schemeClr val="dk1">
                     <a:lumMod val="85000"/>
@@ -20552,7 +20555,7 @@
               <a:t>WSL</a:t>
             </a:r>
             <a:r>
-              <a:rPr lang="zh-TW" sz="1800" b="0" u="none" strike="noStrike">
+              <a:rPr lang="zh-TW" sz="1400" b="0" u="none" strike="noStrike">
                 <a:solidFill>
                   <a:schemeClr val="dk1">
                     <a:lumMod val="85000"/>
@@ -20567,7 +20570,7 @@
               <a:t>系統建立起來</a:t>
             </a:r>
             <a:r>
-              <a:rPr lang="en-US" sz="1800" b="0" u="none" strike="noStrike">
+              <a:rPr lang="en-US" sz="1400" b="0" u="none" strike="noStrike">
                 <a:solidFill>
                   <a:schemeClr val="dk1">
                     <a:lumMod val="85000"/>
@@ -20582,7 +20585,7 @@
               <a:t>,</a:t>
             </a:r>
             <a:r>
-              <a:rPr lang="zh-TW" sz="1800" b="0" u="none" strike="noStrike">
+              <a:rPr lang="zh-TW" sz="1400" b="0" u="none" strike="noStrike">
                 <a:solidFill>
                   <a:schemeClr val="dk1">
                     <a:lumMod val="85000"/>
@@ -20597,17 +20600,18 @@
               <a:t>其他</a:t>
             </a:r>
             <a:r>
-              <a:rPr lang="zh-TW" sz="1800" b="0" u="sng" strike="noStrike">
-                <a:solidFill>
-                  <a:schemeClr val="dk1">
-                    <a:lumMod val="85000"/>
-                    <a:lumOff val="15000"/>
-                  </a:schemeClr>
-                </a:solidFill>
-                <a:effectLst/>
-                <a:uFillTx/>
-                <a:latin typeface="Century Gothic"/>
-                <a:ea typeface="Century Gothic"/>
+              <a:rPr lang="zh-TW" sz="1400" b="0" u="sng" strike="noStrike">
+                <a:solidFill>
+                  <a:schemeClr val="dk1">
+                    <a:lumMod val="85000"/>
+                    <a:lumOff val="15000"/>
+                  </a:schemeClr>
+                </a:solidFill>
+                <a:effectLst/>
+                <a:uFillTx/>
+                <a:latin typeface="Century Gothic"/>
+                <a:ea typeface="Century Gothic"/>
+                <a:hlinkClick r:id="rId5"/>
               </a:rPr>
               <a:t>安裝程式</a:t>
             </a:r>
@@ -20628,6 +20632,9 @@
               <a:lnSpc>
                 <a:spcPts val="2160"/>
               </a:lnSpc>
+              <a:spcAft>
+                <a:spcPts val="300"/>
+              </a:spcAft>
               <a:buClr>
                 <a:srgbClr val="595959"/>
               </a:buClr>
@@ -20639,7 +20646,7 @@
               </a:tabLst>
             </a:pPr>
             <a:r>
-              <a:rPr lang="zh-TW" sz="1800" b="1" u="none" strike="noStrike">
+              <a:rPr lang="zh-TW" sz="1400" b="1" u="none" strike="noStrike">
                 <a:solidFill>
                   <a:schemeClr val="dk1">
                     <a:lumMod val="85000"/>
@@ -20654,7 +20661,7 @@
               <a:t>買家需要自己準備的</a:t>
             </a:r>
             <a:r>
-              <a:rPr lang="en-US" sz="1800" b="1" u="none" strike="noStrike">
+              <a:rPr lang="en-US" sz="1400" b="1" u="none" strike="noStrike">
                 <a:solidFill>
                   <a:schemeClr val="dk1">
                     <a:lumMod val="85000"/>
@@ -20669,7 +20676,7 @@
               <a:t>=&gt;</a:t>
             </a:r>
             <a:r>
-              <a:rPr lang="zh-TW" sz="1800" b="1" u="none" strike="noStrike">
+              <a:rPr lang="zh-TW" sz="1400" b="1" u="none" strike="noStrike">
                 <a:solidFill>
                   <a:schemeClr val="dk1">
                     <a:lumMod val="85000"/>
@@ -20684,7 +20691,7 @@
               <a:t>複製必要的</a:t>
             </a:r>
             <a:r>
-              <a:rPr lang="en-US" sz="1800" b="1" u="none" strike="noStrike">
+              <a:rPr lang="en-US" sz="1400" b="1" u="none" strike="noStrike">
                 <a:solidFill>
                   <a:schemeClr val="dk1">
                     <a:lumMod val="85000"/>
@@ -20699,7 +20706,7 @@
               <a:t>ini.example</a:t>
             </a:r>
             <a:r>
-              <a:rPr lang="zh-TW" sz="1800" b="1" u="none" strike="noStrike">
+              <a:rPr lang="zh-TW" sz="1400" b="1" u="none" strike="noStrike">
                 <a:solidFill>
                   <a:schemeClr val="dk1">
                     <a:lumMod val="85000"/>
@@ -20714,7 +20721,7 @@
               <a:t>成</a:t>
             </a:r>
             <a:r>
-              <a:rPr lang="en-US" sz="1800" b="0" u="none" strike="noStrike">
+              <a:rPr lang="en-US" sz="1400" b="0" u="none" strike="noStrike">
                 <a:solidFill>
                   <a:schemeClr val="dk1">
                     <a:lumMod val="85000"/>
@@ -20729,7 +20736,7 @@
               <a:t>config.simulation.ini,P12</a:t>
             </a:r>
             <a:r>
-              <a:rPr lang="zh-TW" sz="1800" b="0" u="none" strike="noStrike">
+              <a:rPr lang="zh-TW" sz="1400" b="0" u="none" strike="noStrike">
                 <a:solidFill>
                   <a:schemeClr val="dk1">
                     <a:lumMod val="85000"/>
@@ -20744,7 +20751,7 @@
               <a:t>檔…</a:t>
             </a:r>
             <a:r>
-              <a:rPr lang="en-US" sz="1800" b="0" u="none" strike="noStrike">
+              <a:rPr lang="en-US" sz="1400" b="0" u="none" strike="noStrike">
                 <a:solidFill>
                   <a:schemeClr val="dk1">
                     <a:lumMod val="85000"/>
@@ -20775,6 +20782,9 @@
               <a:lnSpc>
                 <a:spcPts val="2160"/>
               </a:lnSpc>
+              <a:spcAft>
+                <a:spcPts val="300"/>
+              </a:spcAft>
               <a:buClr>
                 <a:srgbClr val="595959"/>
               </a:buClr>
@@ -20786,7 +20796,7 @@
               </a:tabLst>
             </a:pPr>
             <a:r>
-              <a:rPr lang="zh-TW" sz="1800" b="0" u="none" strike="noStrike">
+              <a:rPr lang="zh-TW" sz="1400" b="0" u="none" strike="noStrike">
                 <a:solidFill>
                   <a:schemeClr val="dk1">
                     <a:lumMod val="85000"/>
@@ -20801,7 +20811,7 @@
               <a:t>清除原來的</a:t>
             </a:r>
             <a:r>
-              <a:rPr lang="en-US" sz="1800" b="0" u="none" strike="noStrike">
+              <a:rPr lang="en-US" sz="1400" b="0" u="none" strike="noStrike">
                 <a:solidFill>
                   <a:schemeClr val="dk1">
                     <a:lumMod val="85000"/>
@@ -20816,7 +20826,7 @@
               <a:t>~/tw-selfselect/.git, </a:t>
             </a:r>
             <a:r>
-              <a:rPr lang="zh-TW" sz="1800" b="0" u="none" strike="noStrike">
+              <a:rPr lang="zh-TW" sz="1400" b="0" u="none" strike="noStrike">
                 <a:solidFill>
                   <a:schemeClr val="dk1">
                     <a:lumMod val="85000"/>
@@ -20831,7 +20841,7 @@
               <a:t>強烈建議自己申請一個</a:t>
             </a:r>
             <a:r>
-              <a:rPr lang="en-US" sz="1800" b="0" u="sng" strike="noStrike">
+              <a:rPr lang="en-US" sz="1400" b="0" u="sng" strike="noStrike">
                 <a:solidFill>
                   <a:schemeClr val="dk1">
                     <a:lumMod val="85000"/>
@@ -20847,7 +20857,7 @@
               <a:t>git</a:t>
             </a:r>
             <a:r>
-              <a:rPr lang="zh-TW" sz="1800" b="0" u="sng" strike="noStrike">
+              <a:rPr lang="zh-TW" sz="1400" b="0" u="sng" strike="noStrike">
                 <a:solidFill>
                   <a:schemeClr val="dk1">
                     <a:lumMod val="85000"/>
@@ -20863,7 +20873,7 @@
               <a:t>帳戶</a:t>
             </a:r>
             <a:r>
-              <a:rPr lang="zh-TW" sz="1800" b="0" u="none" strike="noStrike">
+              <a:rPr lang="zh-TW" sz="1400" b="0" u="none" strike="noStrike">
                 <a:solidFill>
                   <a:schemeClr val="dk1">
                     <a:lumMod val="85000"/>
@@ -20878,7 +20888,7 @@
               <a:t>如果你要修改程式</a:t>
             </a:r>
             <a:r>
-              <a:rPr lang="en-US" sz="1800" b="0" u="none" strike="noStrike">
+              <a:rPr lang="en-US" sz="1400" b="0" u="none" strike="noStrike">
                 <a:solidFill>
                   <a:schemeClr val="dk1">
                     <a:lumMod val="85000"/>
@@ -20909,6 +20919,9 @@
               <a:lnSpc>
                 <a:spcPts val="2160"/>
               </a:lnSpc>
+              <a:spcAft>
+                <a:spcPts val="300"/>
+              </a:spcAft>
               <a:buClr>
                 <a:srgbClr val="595959"/>
               </a:buClr>
@@ -20920,7 +20933,7 @@
               </a:tabLst>
             </a:pPr>
             <a:r>
-              <a:rPr lang="zh-TW" sz="1800" b="0" u="none" strike="noStrike">
+              <a:rPr lang="zh-TW" sz="1400" b="0" u="none" strike="noStrike">
                 <a:solidFill>
                   <a:schemeClr val="dk1">
                     <a:lumMod val="85000"/>
@@ -20935,7 +20948,7 @@
               <a:t>打開</a:t>
             </a:r>
             <a:r>
-              <a:rPr lang="en-US" sz="1800" b="0" u="none" strike="noStrike">
+              <a:rPr lang="en-US" sz="1400" b="0" u="none" strike="noStrike">
                 <a:solidFill>
                   <a:schemeClr val="dk1">
                     <a:lumMod val="85000"/>
@@ -20950,37 +20963,39 @@
               <a:t>cmd.exe:  wsl –d ubuntu (</a:t>
             </a:r>
             <a:r>
-              <a:rPr lang="en-US" sz="1800" b="0" u="sng" strike="noStrike">
-                <a:solidFill>
-                  <a:schemeClr val="dk1">
-                    <a:lumMod val="85000"/>
-                    <a:lumOff val="15000"/>
-                  </a:schemeClr>
-                </a:solidFill>
-                <a:effectLst/>
-                <a:uFillTx/>
-                <a:latin typeface="Century Gothic"/>
-                <a:ea typeface="Century Gothic"/>
+              <a:rPr lang="en-US" sz="1400" b="0" u="sng" strike="noStrike">
+                <a:solidFill>
+                  <a:schemeClr val="dk1">
+                    <a:lumMod val="85000"/>
+                    <a:lumOff val="15000"/>
+                  </a:schemeClr>
+                </a:solidFill>
+                <a:effectLst/>
+                <a:uFillTx/>
+                <a:latin typeface="Century Gothic"/>
+                <a:ea typeface="Century Gothic"/>
+                <a:hlinkClick r:id="rId3"/>
               </a:rPr>
               <a:t>wsl</a:t>
             </a:r>
             <a:r>
-              <a:rPr lang="zh-TW" sz="1800" b="0" u="sng" strike="noStrike">
-                <a:solidFill>
-                  <a:schemeClr val="dk1">
-                    <a:lumMod val="85000"/>
-                    <a:lumOff val="15000"/>
-                  </a:schemeClr>
-                </a:solidFill>
-                <a:effectLst/>
-                <a:uFillTx/>
-                <a:latin typeface="Century Gothic"/>
-                <a:ea typeface="Century Gothic"/>
+              <a:rPr lang="zh-TW" sz="1400" b="0" u="sng" strike="noStrike">
+                <a:solidFill>
+                  <a:schemeClr val="dk1">
+                    <a:lumMod val="85000"/>
+                    <a:lumOff val="15000"/>
+                  </a:schemeClr>
+                </a:solidFill>
+                <a:effectLst/>
+                <a:uFillTx/>
+                <a:latin typeface="Century Gothic"/>
+                <a:ea typeface="Century Gothic"/>
+                <a:hlinkClick r:id="rId3"/>
               </a:rPr>
               <a:t>簡易說明</a:t>
             </a:r>
             <a:r>
-              <a:rPr lang="en-US" sz="1800" b="0" u="none" strike="noStrike">
+              <a:rPr lang="en-US" sz="1400" b="0" u="none" strike="noStrike">
                 <a:solidFill>
                   <a:schemeClr val="dk1">
                     <a:lumMod val="85000"/>
@@ -21014,6 +21029,9 @@
               <a:spcBef>
                 <a:spcPts val="1800"/>
               </a:spcBef>
+              <a:spcAft>
+                <a:spcPts val="300"/>
+              </a:spcAft>
               <a:buNone/>
               <a:tabLst>
                 <a:tab pos="0" algn="l"/>
@@ -21039,6 +21057,9 @@
               <a:spcBef>
                 <a:spcPts val="1800"/>
               </a:spcBef>
+              <a:spcAft>
+                <a:spcPts val="300"/>
+              </a:spcAft>
               <a:buNone/>
               <a:tabLst>
                 <a:tab pos="0" algn="l"/>
@@ -21064,6 +21085,9 @@
               <a:spcBef>
                 <a:spcPts val="1800"/>
               </a:spcBef>
+              <a:spcAft>
+                <a:spcPts val="300"/>
+              </a:spcAft>
               <a:buNone/>
               <a:tabLst>
                 <a:tab pos="0" algn="l"/>
@@ -21089,6 +21113,9 @@
               <a:spcBef>
                 <a:spcPts val="1800"/>
               </a:spcBef>
+              <a:spcAft>
+                <a:spcPts val="300"/>
+              </a:spcAft>
               <a:buClr>
                 <a:srgbClr val="595959"/>
               </a:buClr>
@@ -21100,7 +21127,7 @@
               </a:tabLst>
             </a:pPr>
             <a:r>
-              <a:rPr lang="zh-TW" sz="1800" b="0" u="none" strike="noStrike">
+              <a:rPr lang="zh-TW" sz="1400" b="0" u="none" strike="noStrike">
                 <a:solidFill>
                   <a:schemeClr val="dk1">
                     <a:lumMod val="85000"/>
@@ -21115,7 +21142,7 @@
               <a:t>電腦有</a:t>
             </a:r>
             <a:r>
-              <a:rPr lang="en-US" sz="1800" b="0" u="none" strike="noStrike">
+              <a:rPr lang="en-US" sz="1400" b="0" u="none" strike="noStrike">
                 <a:solidFill>
                   <a:schemeClr val="dk1">
                     <a:lumMod val="85000"/>
@@ -21130,7 +21157,7 @@
               <a:t>Linux</a:t>
             </a:r>
             <a:r>
-              <a:rPr lang="zh-TW" sz="1800" b="0" u="none" strike="noStrike">
+              <a:rPr lang="zh-TW" sz="1400" b="0" u="none" strike="noStrike">
                 <a:solidFill>
                   <a:schemeClr val="dk1">
                     <a:lumMod val="85000"/>
@@ -21145,7 +21172,7 @@
               <a:t>盤出現</a:t>
             </a:r>
             <a:r>
-              <a:rPr lang="en-US" sz="1800" b="0" u="none" strike="noStrike">
+              <a:rPr lang="en-US" sz="1400" b="0" u="none" strike="noStrike">
                 <a:solidFill>
                   <a:schemeClr val="dk1">
                     <a:lumMod val="85000"/>
@@ -21179,6 +21206,9 @@
               <a:spcBef>
                 <a:spcPts val="1800"/>
               </a:spcBef>
+              <a:spcAft>
+                <a:spcPts val="300"/>
+              </a:spcAft>
               <a:buNone/>
               <a:tabLst>
                 <a:tab pos="0" algn="l"/>
@@ -21207,6 +21237,9 @@
               <a:spcBef>
                 <a:spcPts val="1800"/>
               </a:spcBef>
+              <a:spcAft>
+                <a:spcPts val="300"/>
+              </a:spcAft>
               <a:buNone/>
               <a:tabLst>
                 <a:tab pos="0" algn="l"/>

</xml_diff>